<commit_message>
presentation: 영상 win32com 재임베드 (타 PC 호환) + GitHub Pages 최신화
</commit_message>
<xml_diff>
--- a/portfolio-tracker/presentation/portfolio-tracker-final.pptx
+++ b/portfolio-tracker/presentation/portfolio-tracker-final.pptx
@@ -7,27 +7,27 @@
   <p:sldIdLst>
     <p:sldId id="256" r:id="rId2"/>
     <p:sldId id="257" r:id="rId3"/>
-    <p:sldId id="259" r:id="rId5"/>
-    <p:sldId id="261" r:id="rId7"/>
-    <p:sldId id="269" r:id="rId15"/>
-    <p:sldId id="270" r:id="rId16"/>
-    <p:sldId id="271" r:id="rId17"/>
-    <p:sldId id="272" r:id="rId18"/>
-    <p:sldId id="262" r:id="rId8"/>
-    <p:sldId id="258" r:id="rId4"/>
-    <p:sldId id="273" r:id="rId19"/>
-    <p:sldId id="274" r:id="rId20"/>
-    <p:sldId id="275" r:id="rId21"/>
-    <p:sldId id="265" r:id="rId11"/>
-    <p:sldId id="267" r:id="rId13"/>
-    <p:sldId id="266" r:id="rId12"/>
-    <p:sldId id="278" r:id="rId28"/>
-    <p:sldId id="263" r:id="rId9"/>
-    <p:sldId id="260" r:id="rId6"/>
-    <p:sldId id="264" r:id="rId10"/>
-    <p:sldId id="268" r:id="rId14"/>
-    <p:sldId id="277" r:id="rId22"/>
-    <p:sldId id="276" r:id="rId23"/>
+    <p:sldId id="259" r:id="rId4"/>
+    <p:sldId id="261" r:id="rId5"/>
+    <p:sldId id="269" r:id="rId6"/>
+    <p:sldId id="270" r:id="rId7"/>
+    <p:sldId id="271" r:id="rId8"/>
+    <p:sldId id="272" r:id="rId9"/>
+    <p:sldId id="262" r:id="rId10"/>
+    <p:sldId id="258" r:id="rId11"/>
+    <p:sldId id="273" r:id="rId12"/>
+    <p:sldId id="274" r:id="rId13"/>
+    <p:sldId id="275" r:id="rId14"/>
+    <p:sldId id="265" r:id="rId15"/>
+    <p:sldId id="267" r:id="rId16"/>
+    <p:sldId id="266" r:id="rId17"/>
+    <p:sldId id="278" r:id="rId18"/>
+    <p:sldId id="263" r:id="rId19"/>
+    <p:sldId id="260" r:id="rId20"/>
+    <p:sldId id="264" r:id="rId21"/>
+    <p:sldId id="268" r:id="rId22"/>
+    <p:sldId id="277" r:id="rId23"/>
+    <p:sldId id="276" r:id="rId24"/>
   </p:sldIdLst>
   <p:sldSz cx="12188825" cy="6858000"/>
   <p:notesSz cx="6858000" cy="9144000"/>
@@ -324,7 +324,7 @@
           <a:p>
             <a:fld id="{5BCAD085-E8A6-8845-BD4E-CB4CCA059FC4}" type="datetimeFigureOut">
               <a:rPr lang="en-US" smtClean="0"/>
-              <a:t>6/15/2026</a:t>
+              <a:t>6/16/2026</a:t>
             </a:fld>
             <a:endParaRPr lang="en-US"/>
           </a:p>
@@ -492,7 +492,7 @@
           <a:p>
             <a:fld id="{5BCAD085-E8A6-8845-BD4E-CB4CCA059FC4}" type="datetimeFigureOut">
               <a:rPr lang="en-US" smtClean="0"/>
-              <a:t>6/15/2026</a:t>
+              <a:t>6/16/2026</a:t>
             </a:fld>
             <a:endParaRPr lang="en-US"/>
           </a:p>
@@ -670,7 +670,7 @@
           <a:p>
             <a:fld id="{5BCAD085-E8A6-8845-BD4E-CB4CCA059FC4}" type="datetimeFigureOut">
               <a:rPr lang="en-US" smtClean="0"/>
-              <a:t>6/15/2026</a:t>
+              <a:t>6/16/2026</a:t>
             </a:fld>
             <a:endParaRPr lang="en-US"/>
           </a:p>
@@ -838,7 +838,7 @@
           <a:p>
             <a:fld id="{5BCAD085-E8A6-8845-BD4E-CB4CCA059FC4}" type="datetimeFigureOut">
               <a:rPr lang="en-US" smtClean="0"/>
-              <a:t>6/15/2026</a:t>
+              <a:t>6/16/2026</a:t>
             </a:fld>
             <a:endParaRPr lang="en-US"/>
           </a:p>
@@ -1083,7 +1083,7 @@
           <a:p>
             <a:fld id="{5BCAD085-E8A6-8845-BD4E-CB4CCA059FC4}" type="datetimeFigureOut">
               <a:rPr lang="en-US" smtClean="0"/>
-              <a:t>6/15/2026</a:t>
+              <a:t>6/16/2026</a:t>
             </a:fld>
             <a:endParaRPr lang="en-US"/>
           </a:p>
@@ -1368,7 +1368,7 @@
           <a:p>
             <a:fld id="{5BCAD085-E8A6-8845-BD4E-CB4CCA059FC4}" type="datetimeFigureOut">
               <a:rPr lang="en-US" smtClean="0"/>
-              <a:t>6/15/2026</a:t>
+              <a:t>6/16/2026</a:t>
             </a:fld>
             <a:endParaRPr lang="en-US"/>
           </a:p>
@@ -1787,7 +1787,7 @@
           <a:p>
             <a:fld id="{5BCAD085-E8A6-8845-BD4E-CB4CCA059FC4}" type="datetimeFigureOut">
               <a:rPr lang="en-US" smtClean="0"/>
-              <a:t>6/15/2026</a:t>
+              <a:t>6/16/2026</a:t>
             </a:fld>
             <a:endParaRPr lang="en-US"/>
           </a:p>
@@ -1904,7 +1904,7 @@
           <a:p>
             <a:fld id="{5BCAD085-E8A6-8845-BD4E-CB4CCA059FC4}" type="datetimeFigureOut">
               <a:rPr lang="en-US" smtClean="0"/>
-              <a:t>6/15/2026</a:t>
+              <a:t>6/16/2026</a:t>
             </a:fld>
             <a:endParaRPr lang="en-US"/>
           </a:p>
@@ -1999,7 +1999,7 @@
           <a:p>
             <a:fld id="{5BCAD085-E8A6-8845-BD4E-CB4CCA059FC4}" type="datetimeFigureOut">
               <a:rPr lang="en-US" smtClean="0"/>
-              <a:t>6/15/2026</a:t>
+              <a:t>6/16/2026</a:t>
             </a:fld>
             <a:endParaRPr lang="en-US"/>
           </a:p>
@@ -2274,7 +2274,7 @@
           <a:p>
             <a:fld id="{5BCAD085-E8A6-8845-BD4E-CB4CCA059FC4}" type="datetimeFigureOut">
               <a:rPr lang="en-US" smtClean="0"/>
-              <a:t>6/15/2026</a:t>
+              <a:t>6/16/2026</a:t>
             </a:fld>
             <a:endParaRPr lang="en-US"/>
           </a:p>
@@ -2526,7 +2526,7 @@
           <a:p>
             <a:fld id="{5BCAD085-E8A6-8845-BD4E-CB4CCA059FC4}" type="datetimeFigureOut">
               <a:rPr lang="en-US" smtClean="0"/>
-              <a:t>6/15/2026</a:t>
+              <a:t>6/16/2026</a:t>
             </a:fld>
             <a:endParaRPr lang="en-US"/>
           </a:p>
@@ -2737,7 +2737,7 @@
           <a:p>
             <a:fld id="{5BCAD085-E8A6-8845-BD4E-CB4CCA059FC4}" type="datetimeFigureOut">
               <a:rPr lang="en-US" smtClean="0"/>
-              <a:t>6/15/2026</a:t>
+              <a:t>6/16/2026</a:t>
             </a:fld>
             <a:endParaRPr lang="en-US"/>
           </a:p>
@@ -9293,7 +9293,7 @@
 </file>
 
 <file path=ppt/slides/slide17.xml><?xml version="1.0" encoding="utf-8"?>
-<p:sld xmlns:a="http://schemas.openxmlformats.org/drawingml/2006/main" xmlns:p="http://schemas.openxmlformats.org/presentationml/2006/main" xmlns:r="http://schemas.openxmlformats.org/officeDocument/2006/relationships">
+<p:sld xmlns:a="http://schemas.openxmlformats.org/drawingml/2006/main" xmlns:r="http://schemas.openxmlformats.org/officeDocument/2006/relationships" xmlns:p="http://schemas.openxmlformats.org/presentationml/2006/main">
   <p:cSld>
     <p:spTree>
       <p:nvGrpSpPr>
@@ -9301,7 +9301,14 @@
         <p:cNvGrpSpPr/>
         <p:nvPr/>
       </p:nvGrpSpPr>
-      <p:grpSpPr/>
+      <p:grpSpPr>
+        <a:xfrm>
+          <a:off x="0" y="0"/>
+          <a:ext cx="0" cy="0"/>
+          <a:chOff x="0" y="0"/>
+          <a:chExt cx="0" cy="0"/>
+        </a:xfrm>
+      </p:grpSpPr>
       <p:sp>
         <p:nvSpPr>
           <p:cNvPr id="2" name="Rectangle 1"/>
@@ -9340,6 +9347,7 @@
           <a:lstStyle/>
           <a:p>
             <a:pPr algn="ctr"/>
+            <a:endParaRPr/>
           </a:p>
         </p:txBody>
       </p:sp>
@@ -9451,6 +9459,7 @@
           <a:lstStyle/>
           <a:p>
             <a:pPr algn="ctr"/>
+            <a:endParaRPr/>
           </a:p>
         </p:txBody>
       </p:sp>
@@ -9619,6 +9628,7 @@
           <a:lstStyle/>
           <a:p>
             <a:pPr algn="ctr"/>
+            <a:endParaRPr/>
           </a:p>
         </p:txBody>
       </p:sp>
@@ -9731,6 +9741,7 @@
           <a:lstStyle/>
           <a:p>
             <a:pPr algn="ctr"/>
+            <a:endParaRPr/>
           </a:p>
         </p:txBody>
       </p:sp>
@@ -9842,6 +9853,7 @@
           <a:lstStyle/>
           <a:p>
             <a:pPr algn="ctr"/>
+            <a:endParaRPr/>
           </a:p>
         </p:txBody>
       </p:sp>
@@ -9953,6 +9965,7 @@
           <a:lstStyle/>
           <a:p>
             <a:pPr algn="ctr"/>
+            <a:endParaRPr/>
           </a:p>
         </p:txBody>
       </p:sp>
@@ -14319,8 +14332,13 @@
       </p:grpSpPr>
       <p:pic>
         <p:nvPicPr>
-          <p:cNvPr id="2" name="PortfolioTracker.mp4">
+          <p:cNvPr id="3" name="PortfolioTracker">
             <a:hlinkClick r:id="" action="ppaction://media"/>
+            <a:extLst>
+              <a:ext uri="{FF2B5EF4-FFF2-40B4-BE49-F238E27FC236}">
+                <a16:creationId xmlns:a16="http://schemas.microsoft.com/office/drawing/2014/main" id="{0CAE50B3-397C-EE45-2FF0-AA1718AEEDF7}"/>
+              </a:ext>
+            </a:extLst>
           </p:cNvPr>
           <p:cNvPicPr>
             <a:picLocks noChangeAspect="1"/>
@@ -14342,8 +14360,8 @@
         </p:blipFill>
         <p:spPr>
           <a:xfrm>
-            <a:off x="3931315" y="0"/>
-            <a:ext cx="4326194" cy="6858000"/>
+            <a:off x="0" y="0"/>
+            <a:ext cx="4751273" cy="6858000"/>
           </a:xfrm>
           <a:prstGeom prst="rect">
             <a:avLst/>
@@ -14355,28 +14373,6 @@
   <p:clrMapOvr>
     <a:masterClrMapping/>
   </p:clrMapOvr>
-  <p:timing>
-    <p:tnLst>
-      <p:par>
-        <p:cTn id="1" dur="indefinite" restart="never" nodeType="tmRoot">
-          <p:childTnLst>
-            <p:video>
-              <p:cMediaNode vol="80000">
-                <p:cTn id="2" fill="hold" display="0">
-                  <p:stCondLst>
-                    <p:cond delay="indefinite"/>
-                  </p:stCondLst>
-                </p:cTn>
-                <p:tgtEl>
-                  <p:spTgt spid="2"/>
-                </p:tgtEl>
-              </p:cMediaNode>
-            </p:video>
-          </p:childTnLst>
-        </p:cTn>
-      </p:par>
-    </p:tnLst>
-  </p:timing>
 </p:sld>
 </file>
 

</xml_diff>